<commit_message>
Landing comercial publica + login hacia /panel; propuesta: funcionalidades detalladas y contacto
</commit_message>
<xml_diff>
--- a/docs/propuesta-comercial.pptx
+++ b/docs/propuesta-comercial.pptx
@@ -4345,8 +4345,8 @@
         </p:nvSpPr>
         <p:spPr>
           <a:xfrm>
-            <a:off x="640080" y="1463040"/>
-            <a:ext cx="5257800" cy="1371600"/>
+            <a:off x="640080" y="1371600"/>
+            <a:ext cx="5257800" cy="1078992"/>
           </a:xfrm>
           <a:prstGeom prst="rect">
             <a:avLst/>
@@ -4391,8 +4391,8 @@
         </p:nvSpPr>
         <p:spPr>
           <a:xfrm>
-            <a:off x="640080" y="1463040"/>
-            <a:ext cx="63500" cy="1371600"/>
+            <a:off x="640080" y="1371600"/>
+            <a:ext cx="63500" cy="1078992"/>
           </a:xfrm>
           <a:prstGeom prst="rect">
             <a:avLst/>
@@ -4435,8 +4435,8 @@
         </p:nvSpPr>
         <p:spPr>
           <a:xfrm>
-            <a:off x="914400" y="1627632"/>
-            <a:ext cx="4846320" cy="1097280"/>
+            <a:off x="914400" y="1499616"/>
+            <a:ext cx="4846320" cy="868680"/>
           </a:xfrm>
           <a:prstGeom prst="rect">
             <a:avLst/>
@@ -4451,17 +4451,17 @@
           <a:p>
             <a:pPr algn="l">
               <a:spcAft>
-                <a:spcPts val="300"/>
+                <a:spcPts val="200"/>
               </a:spcAft>
             </a:pPr>
             <a:r>
-              <a:rPr sz="1500" b="1" i="0">
+              <a:rPr sz="1400" b="1" i="0">
                 <a:solidFill>
                   <a:srgbClr val="7E0704"/>
                 </a:solidFill>
                 <a:latin typeface="Calibri"/>
               </a:rPr>
-              <a:t>🪂 Cursos</a:t>
+              <a:t>🌐 Página web comercial</a:t>
             </a:r>
           </a:p>
           <a:p>
@@ -4471,13 +4471,13 @@
               </a:spcAft>
             </a:pPr>
             <a:r>
-              <a:rPr sz="1250" b="0" i="0">
+              <a:rPr sz="1150" b="0" i="0">
                 <a:solidFill>
                   <a:srgbClr val="16130F"/>
                 </a:solidFill>
                 <a:latin typeface="Calibri"/>
               </a:rPr>
-              <a:t>Catálogo (AFF, Tándem…), temario, precios, videos y manuales.</a:t>
+              <a:t>Página pública con cursos y botones de WhatsApp e inicio de sesión.</a:t>
             </a:r>
           </a:p>
         </p:txBody>
@@ -4490,8 +4490,8 @@
         </p:nvSpPr>
         <p:spPr>
           <a:xfrm>
-            <a:off x="6309360" y="1463040"/>
-            <a:ext cx="5257800" cy="1371600"/>
+            <a:off x="6309360" y="1371600"/>
+            <a:ext cx="5257800" cy="1078992"/>
           </a:xfrm>
           <a:prstGeom prst="rect">
             <a:avLst/>
@@ -4536,8 +4536,8 @@
         </p:nvSpPr>
         <p:spPr>
           <a:xfrm>
-            <a:off x="6309360" y="1463040"/>
-            <a:ext cx="63500" cy="1371600"/>
+            <a:off x="6309360" y="1371600"/>
+            <a:ext cx="63500" cy="1078992"/>
           </a:xfrm>
           <a:prstGeom prst="rect">
             <a:avLst/>
@@ -4580,8 +4580,8 @@
         </p:nvSpPr>
         <p:spPr>
           <a:xfrm>
-            <a:off x="6583680" y="1627632"/>
-            <a:ext cx="4846320" cy="1097280"/>
+            <a:off x="6583680" y="1499616"/>
+            <a:ext cx="4846320" cy="868680"/>
           </a:xfrm>
           <a:prstGeom prst="rect">
             <a:avLst/>
@@ -4596,17 +4596,17 @@
           <a:p>
             <a:pPr algn="l">
               <a:spcAft>
-                <a:spcPts val="300"/>
+                <a:spcPts val="200"/>
               </a:spcAft>
             </a:pPr>
             <a:r>
-              <a:rPr sz="1500" b="1" i="0">
+              <a:rPr sz="1400" b="1" i="0">
                 <a:solidFill>
                   <a:srgbClr val="7E0704"/>
                 </a:solidFill>
                 <a:latin typeface="Calibri"/>
               </a:rPr>
-              <a:t>🎓 Estudiantes</a:t>
+              <a:t>🪂 Cursos</a:t>
             </a:r>
           </a:p>
           <a:p>
@@ -4616,13 +4616,13 @@
               </a:spcAft>
             </a:pPr>
             <a:r>
-              <a:rPr sz="1250" b="0" i="0">
+              <a:rPr sz="1150" b="0" i="0">
                 <a:solidFill>
                   <a:srgbClr val="16130F"/>
                 </a:solidFill>
                 <a:latin typeface="Calibri"/>
               </a:rPr>
-              <a:t>Fichas completas y bitácora de saltos por nivel.</a:t>
+              <a:t>Catálogo (AFF, Tándem…), temario, precios, videos y manuales (PDF/YouTube).</a:t>
             </a:r>
           </a:p>
         </p:txBody>
@@ -4635,8 +4635,8 @@
         </p:nvSpPr>
         <p:spPr>
           <a:xfrm>
-            <a:off x="640080" y="3063240"/>
-            <a:ext cx="5257800" cy="1371600"/>
+            <a:off x="640080" y="2587752"/>
+            <a:ext cx="5257800" cy="1078992"/>
           </a:xfrm>
           <a:prstGeom prst="rect">
             <a:avLst/>
@@ -4681,8 +4681,8 @@
         </p:nvSpPr>
         <p:spPr>
           <a:xfrm>
-            <a:off x="640080" y="3063240"/>
-            <a:ext cx="63500" cy="1371600"/>
+            <a:off x="640080" y="2587752"/>
+            <a:ext cx="63500" cy="1078992"/>
           </a:xfrm>
           <a:prstGeom prst="rect">
             <a:avLst/>
@@ -4725,8 +4725,8 @@
         </p:nvSpPr>
         <p:spPr>
           <a:xfrm>
-            <a:off x="914400" y="3227832"/>
-            <a:ext cx="4846320" cy="1097280"/>
+            <a:off x="914400" y="2715768"/>
+            <a:ext cx="4846320" cy="868680"/>
           </a:xfrm>
           <a:prstGeom prst="rect">
             <a:avLst/>
@@ -4741,17 +4741,17 @@
           <a:p>
             <a:pPr algn="l">
               <a:spcAft>
-                <a:spcPts val="300"/>
+                <a:spcPts val="200"/>
               </a:spcAft>
             </a:pPr>
             <a:r>
-              <a:rPr sz="1500" b="1" i="0">
+              <a:rPr sz="1400" b="1" i="0">
                 <a:solidFill>
                   <a:srgbClr val="7E0704"/>
                 </a:solidFill>
                 <a:latin typeface="Calibri"/>
               </a:rPr>
-              <a:t>💳 Finanzas</a:t>
+              <a:t>🎓 Estudiantes</a:t>
             </a:r>
           </a:p>
           <a:p>
@@ -4761,13 +4761,13 @@
               </a:spcAft>
             </a:pPr>
             <a:r>
-              <a:rPr sz="1250" b="0" i="0">
+              <a:rPr sz="1150" b="0" i="0">
                 <a:solidFill>
                   <a:srgbClr val="16130F"/>
                 </a:solidFill>
                 <a:latin typeface="Calibri"/>
               </a:rPr>
-              <a:t>Pagos, cartera por cobrar y nómina de instructores.</a:t>
+              <a:t>Fichas completas y bitácora de saltos por nivel.</a:t>
             </a:r>
           </a:p>
         </p:txBody>
@@ -4780,8 +4780,8 @@
         </p:nvSpPr>
         <p:spPr>
           <a:xfrm>
-            <a:off x="6309360" y="3063240"/>
-            <a:ext cx="5257800" cy="1371600"/>
+            <a:off x="6309360" y="2587752"/>
+            <a:ext cx="5257800" cy="1078992"/>
           </a:xfrm>
           <a:prstGeom prst="rect">
             <a:avLst/>
@@ -4826,8 +4826,8 @@
         </p:nvSpPr>
         <p:spPr>
           <a:xfrm>
-            <a:off x="6309360" y="3063240"/>
-            <a:ext cx="63500" cy="1371600"/>
+            <a:off x="6309360" y="2587752"/>
+            <a:ext cx="63500" cy="1078992"/>
           </a:xfrm>
           <a:prstGeom prst="rect">
             <a:avLst/>
@@ -4870,8 +4870,8 @@
         </p:nvSpPr>
         <p:spPr>
           <a:xfrm>
-            <a:off x="6583680" y="3227832"/>
-            <a:ext cx="4846320" cy="1097280"/>
+            <a:off x="6583680" y="2715768"/>
+            <a:ext cx="4846320" cy="868680"/>
           </a:xfrm>
           <a:prstGeom prst="rect">
             <a:avLst/>
@@ -4886,17 +4886,17 @@
           <a:p>
             <a:pPr algn="l">
               <a:spcAft>
-                <a:spcPts val="300"/>
+                <a:spcPts val="200"/>
               </a:spcAft>
             </a:pPr>
             <a:r>
-              <a:rPr sz="1500" b="1" i="0">
+              <a:rPr sz="1400" b="1" i="0">
                 <a:solidFill>
                   <a:srgbClr val="7E0704"/>
                 </a:solidFill>
                 <a:latin typeface="Calibri"/>
               </a:rPr>
-              <a:t>📋 Manifiesto</a:t>
+              <a:t>💳 Finanzas</a:t>
             </a:r>
           </a:p>
           <a:p>
@@ -4906,13 +4906,13 @@
               </a:spcAft>
             </a:pPr>
             <a:r>
-              <a:rPr sz="1250" b="0" i="0">
+              <a:rPr sz="1150" b="0" i="0">
                 <a:solidFill>
                   <a:srgbClr val="16130F"/>
                 </a:solidFill>
                 <a:latin typeface="Calibri"/>
               </a:rPr>
-              <a:t>Jornadas, vuelos y quién va en cada vuelo.</a:t>
+              <a:t>Pagos, cartera por cobrar y nómina de instructores.</a:t>
             </a:r>
           </a:p>
         </p:txBody>
@@ -4925,8 +4925,8 @@
         </p:nvSpPr>
         <p:spPr>
           <a:xfrm>
-            <a:off x="640080" y="4663440"/>
-            <a:ext cx="5257800" cy="1371600"/>
+            <a:off x="640080" y="3803904"/>
+            <a:ext cx="5257800" cy="1078992"/>
           </a:xfrm>
           <a:prstGeom prst="rect">
             <a:avLst/>
@@ -4971,8 +4971,8 @@
         </p:nvSpPr>
         <p:spPr>
           <a:xfrm>
-            <a:off x="640080" y="4663440"/>
-            <a:ext cx="63500" cy="1371600"/>
+            <a:off x="640080" y="3803904"/>
+            <a:ext cx="63500" cy="1078992"/>
           </a:xfrm>
           <a:prstGeom prst="rect">
             <a:avLst/>
@@ -5015,8 +5015,8 @@
         </p:nvSpPr>
         <p:spPr>
           <a:xfrm>
-            <a:off x="914400" y="4828032"/>
-            <a:ext cx="4846320" cy="1097280"/>
+            <a:off x="914400" y="3931920"/>
+            <a:ext cx="4846320" cy="868680"/>
           </a:xfrm>
           <a:prstGeom prst="rect">
             <a:avLst/>
@@ -5031,17 +5031,17 @@
           <a:p>
             <a:pPr algn="l">
               <a:spcAft>
-                <a:spcPts val="300"/>
+                <a:spcPts val="200"/>
               </a:spcAft>
             </a:pPr>
             <a:r>
-              <a:rPr sz="1500" b="1" i="0">
+              <a:rPr sz="1400" b="1" i="0">
                 <a:solidFill>
                   <a:srgbClr val="7E0704"/>
                 </a:solidFill>
                 <a:latin typeface="Calibri"/>
               </a:rPr>
-              <a:t>✉️ Notificaciones</a:t>
+              <a:t>📋 Manifiesto</a:t>
             </a:r>
           </a:p>
           <a:p>
@@ -5051,13 +5051,13 @@
               </a:spcAft>
             </a:pPr>
             <a:r>
-              <a:rPr sz="1250" b="0" i="0">
+              <a:rPr sz="1150" b="0" i="0">
                 <a:solidFill>
                   <a:srgbClr val="16130F"/>
                 </a:solidFill>
                 <a:latin typeface="Calibri"/>
               </a:rPr>
-              <a:t>Correos programables: recordatorio y oferta de curso.</a:t>
+              <a:t>Jornadas, vuelos y quién va en cada vuelo.</a:t>
             </a:r>
           </a:p>
         </p:txBody>
@@ -5070,8 +5070,8 @@
         </p:nvSpPr>
         <p:spPr>
           <a:xfrm>
-            <a:off x="6309360" y="4663440"/>
-            <a:ext cx="5257800" cy="1371600"/>
+            <a:off x="6309360" y="3803904"/>
+            <a:ext cx="5257800" cy="1078992"/>
           </a:xfrm>
           <a:prstGeom prst="rect">
             <a:avLst/>
@@ -5116,8 +5116,8 @@
         </p:nvSpPr>
         <p:spPr>
           <a:xfrm>
-            <a:off x="6309360" y="4663440"/>
-            <a:ext cx="63500" cy="1371600"/>
+            <a:off x="6309360" y="3803904"/>
+            <a:ext cx="63500" cy="1078992"/>
           </a:xfrm>
           <a:prstGeom prst="rect">
             <a:avLst/>
@@ -5160,8 +5160,8 @@
         </p:nvSpPr>
         <p:spPr>
           <a:xfrm>
-            <a:off x="6583680" y="4828032"/>
-            <a:ext cx="4846320" cy="1097280"/>
+            <a:off x="6583680" y="3931920"/>
+            <a:ext cx="4846320" cy="868680"/>
           </a:xfrm>
           <a:prstGeom prst="rect">
             <a:avLst/>
@@ -5176,17 +5176,17 @@
           <a:p>
             <a:pPr algn="l">
               <a:spcAft>
-                <a:spcPts val="300"/>
+                <a:spcPts val="200"/>
               </a:spcAft>
             </a:pPr>
             <a:r>
-              <a:rPr sz="1500" b="1" i="0">
+              <a:rPr sz="1400" b="1" i="0">
                 <a:solidFill>
                   <a:srgbClr val="7E0704"/>
                 </a:solidFill>
                 <a:latin typeface="Calibri"/>
               </a:rPr>
-              <a:t>👥 Roles + PWA</a:t>
+              <a:t>✉️ Notificaciones</a:t>
             </a:r>
           </a:p>
           <a:p>
@@ -5196,13 +5196,303 @@
               </a:spcAft>
             </a:pPr>
             <a:r>
-              <a:rPr sz="1250" b="0" i="0">
+              <a:rPr sz="1150" b="0" i="0">
                 <a:solidFill>
                   <a:srgbClr val="16130F"/>
                 </a:solidFill>
                 <a:latin typeface="Calibri"/>
               </a:rPr>
-              <a:t>Admin, Instructor y Estudiante. App instalable en el celular.</a:t>
+              <a:t>Correos programables: recordatorio y oferta de curso.</a:t>
+            </a:r>
+          </a:p>
+        </p:txBody>
+      </p:sp>
+      <p:sp>
+        <p:nvSpPr>
+          <p:cNvPr id="25" name="Rectangle 24"/>
+          <p:cNvSpPr/>
+          <p:nvPr/>
+        </p:nvSpPr>
+        <p:spPr>
+          <a:xfrm>
+            <a:off x="640080" y="5020056"/>
+            <a:ext cx="5257800" cy="1078992"/>
+          </a:xfrm>
+          <a:prstGeom prst="rect">
+            <a:avLst/>
+          </a:prstGeom>
+          <a:solidFill>
+            <a:srgbClr val="FFFFFF"/>
+          </a:solidFill>
+          <a:ln>
+            <a:solidFill>
+              <a:srgbClr val="E7DED2"/>
+            </a:solidFill>
+          </a:ln>
+          <a:effectLst/>
+        </p:spPr>
+        <p:style>
+          <a:lnRef idx="1">
+            <a:schemeClr val="accent1"/>
+          </a:lnRef>
+          <a:fillRef idx="3">
+            <a:schemeClr val="accent1"/>
+          </a:fillRef>
+          <a:effectRef idx="2">
+            <a:schemeClr val="accent1"/>
+          </a:effectRef>
+          <a:fontRef idx="minor">
+            <a:schemeClr val="lt1"/>
+          </a:fontRef>
+        </p:style>
+        <p:txBody>
+          <a:bodyPr rtlCol="0" anchor="ctr"/>
+          <a:lstStyle/>
+          <a:p>
+            <a:pPr algn="ctr"/>
+          </a:p>
+        </p:txBody>
+      </p:sp>
+      <p:sp>
+        <p:nvSpPr>
+          <p:cNvPr id="26" name="Rectangle 25"/>
+          <p:cNvSpPr/>
+          <p:nvPr/>
+        </p:nvSpPr>
+        <p:spPr>
+          <a:xfrm>
+            <a:off x="640080" y="5020056"/>
+            <a:ext cx="63500" cy="1078992"/>
+          </a:xfrm>
+          <a:prstGeom prst="rect">
+            <a:avLst/>
+          </a:prstGeom>
+          <a:solidFill>
+            <a:srgbClr val="A93037"/>
+          </a:solidFill>
+          <a:ln>
+            <a:noFill/>
+          </a:ln>
+          <a:effectLst/>
+        </p:spPr>
+        <p:style>
+          <a:lnRef idx="1">
+            <a:schemeClr val="accent1"/>
+          </a:lnRef>
+          <a:fillRef idx="3">
+            <a:schemeClr val="accent1"/>
+          </a:fillRef>
+          <a:effectRef idx="2">
+            <a:schemeClr val="accent1"/>
+          </a:effectRef>
+          <a:fontRef idx="minor">
+            <a:schemeClr val="lt1"/>
+          </a:fontRef>
+        </p:style>
+        <p:txBody>
+          <a:bodyPr rtlCol="0" anchor="ctr"/>
+          <a:lstStyle/>
+          <a:p>
+            <a:pPr algn="ctr"/>
+          </a:p>
+        </p:txBody>
+      </p:sp>
+      <p:sp>
+        <p:nvSpPr>
+          <p:cNvPr id="27" name="TextBox 26"/>
+          <p:cNvSpPr txBox="1"/>
+          <p:nvPr/>
+        </p:nvSpPr>
+        <p:spPr>
+          <a:xfrm>
+            <a:off x="914400" y="5148072"/>
+            <a:ext cx="4846320" cy="868680"/>
+          </a:xfrm>
+          <a:prstGeom prst="rect">
+            <a:avLst/>
+          </a:prstGeom>
+          <a:noFill/>
+        </p:spPr>
+        <p:txBody>
+          <a:bodyPr wrap="square" anchor="t" lIns="0" rIns="0" tIns="0" bIns="0">
+            <a:spAutoFit/>
+          </a:bodyPr>
+          <a:lstStyle/>
+          <a:p>
+            <a:pPr algn="l">
+              <a:spcAft>
+                <a:spcPts val="200"/>
+              </a:spcAft>
+            </a:pPr>
+            <a:r>
+              <a:rPr sz="1400" b="1" i="0">
+                <a:solidFill>
+                  <a:srgbClr val="7E0704"/>
+                </a:solidFill>
+                <a:latin typeface="Calibri"/>
+              </a:rPr>
+              <a:t>👥 Roles + portal</a:t>
+            </a:r>
+          </a:p>
+          <a:p>
+            <a:pPr algn="l">
+              <a:spcAft>
+                <a:spcPts val="600"/>
+              </a:spcAft>
+            </a:pPr>
+            <a:r>
+              <a:rPr sz="1150" b="0" i="0">
+                <a:solidFill>
+                  <a:srgbClr val="16130F"/>
+                </a:solidFill>
+                <a:latin typeface="Calibri"/>
+              </a:rPr>
+              <a:t>Admin, Instructor y Estudiante. Portal del estudiante.</a:t>
+            </a:r>
+          </a:p>
+        </p:txBody>
+      </p:sp>
+      <p:sp>
+        <p:nvSpPr>
+          <p:cNvPr id="28" name="Rectangle 27"/>
+          <p:cNvSpPr/>
+          <p:nvPr/>
+        </p:nvSpPr>
+        <p:spPr>
+          <a:xfrm>
+            <a:off x="6309360" y="5020056"/>
+            <a:ext cx="5257800" cy="1078992"/>
+          </a:xfrm>
+          <a:prstGeom prst="rect">
+            <a:avLst/>
+          </a:prstGeom>
+          <a:solidFill>
+            <a:srgbClr val="FFFFFF"/>
+          </a:solidFill>
+          <a:ln>
+            <a:solidFill>
+              <a:srgbClr val="E7DED2"/>
+            </a:solidFill>
+          </a:ln>
+          <a:effectLst/>
+        </p:spPr>
+        <p:style>
+          <a:lnRef idx="1">
+            <a:schemeClr val="accent1"/>
+          </a:lnRef>
+          <a:fillRef idx="3">
+            <a:schemeClr val="accent1"/>
+          </a:fillRef>
+          <a:effectRef idx="2">
+            <a:schemeClr val="accent1"/>
+          </a:effectRef>
+          <a:fontRef idx="minor">
+            <a:schemeClr val="lt1"/>
+          </a:fontRef>
+        </p:style>
+        <p:txBody>
+          <a:bodyPr rtlCol="0" anchor="ctr"/>
+          <a:lstStyle/>
+          <a:p>
+            <a:pPr algn="ctr"/>
+          </a:p>
+        </p:txBody>
+      </p:sp>
+      <p:sp>
+        <p:nvSpPr>
+          <p:cNvPr id="29" name="Rectangle 28"/>
+          <p:cNvSpPr/>
+          <p:nvPr/>
+        </p:nvSpPr>
+        <p:spPr>
+          <a:xfrm>
+            <a:off x="6309360" y="5020056"/>
+            <a:ext cx="63500" cy="1078992"/>
+          </a:xfrm>
+          <a:prstGeom prst="rect">
+            <a:avLst/>
+          </a:prstGeom>
+          <a:solidFill>
+            <a:srgbClr val="A93037"/>
+          </a:solidFill>
+          <a:ln>
+            <a:noFill/>
+          </a:ln>
+          <a:effectLst/>
+        </p:spPr>
+        <p:style>
+          <a:lnRef idx="1">
+            <a:schemeClr val="accent1"/>
+          </a:lnRef>
+          <a:fillRef idx="3">
+            <a:schemeClr val="accent1"/>
+          </a:fillRef>
+          <a:effectRef idx="2">
+            <a:schemeClr val="accent1"/>
+          </a:effectRef>
+          <a:fontRef idx="minor">
+            <a:schemeClr val="lt1"/>
+          </a:fontRef>
+        </p:style>
+        <p:txBody>
+          <a:bodyPr rtlCol="0" anchor="ctr"/>
+          <a:lstStyle/>
+          <a:p>
+            <a:pPr algn="ctr"/>
+          </a:p>
+        </p:txBody>
+      </p:sp>
+      <p:sp>
+        <p:nvSpPr>
+          <p:cNvPr id="30" name="TextBox 29"/>
+          <p:cNvSpPr txBox="1"/>
+          <p:nvPr/>
+        </p:nvSpPr>
+        <p:spPr>
+          <a:xfrm>
+            <a:off x="6583680" y="5148072"/>
+            <a:ext cx="4846320" cy="868680"/>
+          </a:xfrm>
+          <a:prstGeom prst="rect">
+            <a:avLst/>
+          </a:prstGeom>
+          <a:noFill/>
+        </p:spPr>
+        <p:txBody>
+          <a:bodyPr wrap="square" anchor="t" lIns="0" rIns="0" tIns="0" bIns="0">
+            <a:spAutoFit/>
+          </a:bodyPr>
+          <a:lstStyle/>
+          <a:p>
+            <a:pPr algn="l">
+              <a:spcAft>
+                <a:spcPts val="200"/>
+              </a:spcAft>
+            </a:pPr>
+            <a:r>
+              <a:rPr sz="1400" b="1" i="0">
+                <a:solidFill>
+                  <a:srgbClr val="7E0704"/>
+                </a:solidFill>
+                <a:latin typeface="Calibri"/>
+              </a:rPr>
+              <a:t>📱 App PWA + URL/HTTPS</a:t>
+            </a:r>
+          </a:p>
+          <a:p>
+            <a:pPr algn="l">
+              <a:spcAft>
+                <a:spcPts val="600"/>
+              </a:spcAft>
+            </a:pPr>
+            <a:r>
+              <a:rPr sz="1150" b="0" i="0">
+                <a:solidFill>
+                  <a:srgbClr val="16130F"/>
+                </a:solidFill>
+                <a:latin typeface="Calibri"/>
+              </a:rPr>
+              <a:t>Instalable con marca, publicada con dominio seguro.</a:t>
             </a:r>
           </a:p>
         </p:txBody>
@@ -9059,8 +9349,8 @@
         </p:nvSpPr>
         <p:spPr>
           <a:xfrm>
-            <a:off x="822960" y="2194560"/>
-            <a:ext cx="10515600" cy="2926080"/>
+            <a:off x="822960" y="2148840"/>
+            <a:ext cx="10515600" cy="2651760"/>
           </a:xfrm>
           <a:prstGeom prst="rect">
             <a:avLst/>
@@ -9075,11 +9365,11 @@
           <a:p>
             <a:pPr algn="l">
               <a:spcAft>
-                <a:spcPts val="1200"/>
+                <a:spcPts val="1000"/>
               </a:spcAft>
             </a:pPr>
             <a:r>
-              <a:rPr sz="1600" b="0" i="0">
+              <a:rPr sz="1500" b="0" i="0">
                 <a:solidFill>
                   <a:srgbClr val="16130F"/>
                 </a:solidFill>
@@ -9091,11 +9381,11 @@
           <a:p>
             <a:pPr algn="l">
               <a:spcAft>
-                <a:spcPts val="1200"/>
+                <a:spcPts val="1000"/>
               </a:spcAft>
             </a:pPr>
             <a:r>
-              <a:rPr sz="1600" b="0" i="0">
+              <a:rPr sz="1500" b="0" i="0">
                 <a:solidFill>
                   <a:srgbClr val="16130F"/>
                 </a:solidFill>
@@ -9107,11 +9397,11 @@
           <a:p>
             <a:pPr algn="l">
               <a:spcAft>
-                <a:spcPts val="1200"/>
+                <a:spcPts val="1000"/>
               </a:spcAft>
             </a:pPr>
             <a:r>
-              <a:rPr sz="1600" b="0" i="0">
+              <a:rPr sz="1500" b="0" i="0">
                 <a:solidFill>
                   <a:srgbClr val="16130F"/>
                 </a:solidFill>
@@ -9123,11 +9413,11 @@
           <a:p>
             <a:pPr algn="l">
               <a:spcAft>
-                <a:spcPts val="1200"/>
+                <a:spcPts val="1000"/>
               </a:spcAft>
             </a:pPr>
             <a:r>
-              <a:rPr sz="1600" b="0" i="0">
+              <a:rPr sz="1500" b="0" i="0">
                 <a:solidFill>
                   <a:srgbClr val="16130F"/>
                 </a:solidFill>
@@ -9139,11 +9429,11 @@
           <a:p>
             <a:pPr algn="l">
               <a:spcAft>
-                <a:spcPts val="1200"/>
+                <a:spcPts val="1000"/>
               </a:spcAft>
             </a:pPr>
             <a:r>
-              <a:rPr sz="1600" b="0" i="0">
+              <a:rPr sz="1500" b="0" i="0">
                 <a:solidFill>
                   <a:srgbClr val="16130F"/>
                 </a:solidFill>
@@ -9162,14 +9452,14 @@
         </p:nvSpPr>
         <p:spPr>
           <a:xfrm>
-            <a:off x="640080" y="5532120"/>
-            <a:ext cx="10881360" cy="685800"/>
+            <a:off x="640080" y="5029200"/>
+            <a:ext cx="10881360" cy="1188720"/>
           </a:xfrm>
           <a:prstGeom prst="rect">
             <a:avLst/>
           </a:prstGeom>
           <a:solidFill>
-            <a:srgbClr val="F2B705"/>
+            <a:srgbClr val="7E0704"/>
           </a:solidFill>
           <a:ln>
             <a:noFill/>
@@ -9206,8 +9496,8 @@
         </p:nvSpPr>
         <p:spPr>
           <a:xfrm>
-            <a:off x="914400" y="5596128"/>
-            <a:ext cx="10332720" cy="548640"/>
+            <a:off x="914400" y="5138928"/>
+            <a:ext cx="10332720" cy="1005840"/>
           </a:xfrm>
           <a:prstGeom prst="rect">
             <a:avLst/>
@@ -9219,6 +9509,22 @@
             <a:spAutoFit/>
           </a:bodyPr>
           <a:lstStyle/>
+          <a:p>
+            <a:pPr algn="ctr">
+              <a:spcAft>
+                <a:spcPts val="500"/>
+              </a:spcAft>
+            </a:pPr>
+            <a:r>
+              <a:rPr sz="1900" b="1" i="0">
+                <a:solidFill>
+                  <a:srgbClr val="FFFFFF"/>
+                </a:solidFill>
+                <a:latin typeface="Calibri"/>
+              </a:rPr>
+              <a:t>📱  Contacto: Julián Castaño   ·   WhatsApp +57 318 846 8892</a:t>
+            </a:r>
+          </a:p>
           <a:p>
             <a:pPr algn="ctr">
               <a:spcAft>
@@ -9226,9 +9532,9 @@
               </a:spcAft>
             </a:pPr>
             <a:r>
-              <a:rPr sz="1500" b="1" i="0">
-                <a:solidFill>
-                  <a:srgbClr val="5C0503"/>
+              <a:rPr sz="1300" b="0" i="0">
+                <a:solidFill>
+                  <a:srgbClr val="F2B705"/>
                 </a:solidFill>
                 <a:latin typeface="Calibri"/>
               </a:rPr>

</xml_diff>

<commit_message>
Responsive movil reforzado; quitar API/Docs del menu; propuesta a $6.000.000
</commit_message>
<xml_diff>
--- a/docs/propuesta-comercial.pptx
+++ b/docs/propuesta-comercial.pptx
@@ -5991,7 +5991,7 @@
                 </a:solidFill>
                 <a:latin typeface="Calibri"/>
               </a:rPr>
-              <a:t>$5.500.000 COP</a:t>
+              <a:t>$6.000.000 COP</a:t>
             </a:r>
           </a:p>
           <a:p>
@@ -6329,7 +6329,7 @@
                 </a:solidFill>
                 <a:latin typeface="Calibri"/>
               </a:rPr>
-              <a:t>Precio total (llave en mano): $5.500.000 COP</a:t>
+              <a:t>Precio total (llave en mano): $6.000.000 COP</a:t>
             </a:r>
           </a:p>
         </p:txBody>
@@ -6482,7 +6482,7 @@
                           </a:solidFill>
                           <a:latin typeface="Calibri"/>
                         </a:rPr>
-                        <a:t>$2.750.000 COP</a:t>
+                        <a:t>$3.000.000 COP</a:t>
                       </a:r>
                     </a:p>
                   </a:txBody>
@@ -6550,7 +6550,7 @@
                           </a:solidFill>
                           <a:latin typeface="Calibri"/>
                         </a:rPr>
-                        <a:t>$2.750.000 COP</a:t>
+                        <a:t>$3.000.000 COP</a:t>
                       </a:r>
                     </a:p>
                   </a:txBody>
@@ -9037,7 +9037,7 @@
                 </a:solidFill>
                 <a:latin typeface="Calibri"/>
               </a:rPr>
-              <a:t>Se paga con menos de 1 curso AFF</a:t>
+              <a:t>Cuesta menos que 1 curso AFF</a:t>
             </a:r>
           </a:p>
           <a:p>
@@ -9053,7 +9053,7 @@
                 </a:solidFill>
                 <a:latin typeface="Calibri"/>
               </a:rPr>
-              <a:t>Precio $5.500.000 + operación ~$1.000.000/año  &lt;  un curso AFF $6.333.333. Si ayuda a cerrar un solo estudiante adicional al año, la inversión queda cubierta.</a:t>
+              <a:t>Precio $6.000.000 + operación ~$1.000.000/año  &lt;  un curso AFF $6.333.333. Si ayuda a cerrar un solo estudiante adicional al año, la inversión queda cubierta.</a:t>
             </a:r>
           </a:p>
         </p:txBody>

</xml_diff>